<commit_message>
Updated ppt and src references
</commit_message>
<xml_diff>
--- a/Resources/Project.pptx
+++ b/Resources/Project.pptx
@@ -1076,7 +1076,7 @@
           <a:p>
             <a:fld id="{7EC150B0-FB0A-4485-A89E-5A9600F4FCC2}" type="datetimeFigureOut">
               <a:rPr lang="en-US" smtClean="0"/>
-              <a:t>3/4/2026</a:t>
+              <a:t>5/1/2026</a:t>
             </a:fld>
             <a:endParaRPr lang="en-US"/>
           </a:p>
@@ -1275,7 +1275,7 @@
           <a:p>
             <a:fld id="{7EC150B0-FB0A-4485-A89E-5A9600F4FCC2}" type="datetimeFigureOut">
               <a:rPr lang="en-US" smtClean="0"/>
-              <a:t>3/4/2026</a:t>
+              <a:t>5/1/2026</a:t>
             </a:fld>
             <a:endParaRPr lang="en-US"/>
           </a:p>
@@ -1484,7 +1484,7 @@
           <a:p>
             <a:fld id="{7EC150B0-FB0A-4485-A89E-5A9600F4FCC2}" type="datetimeFigureOut">
               <a:rPr lang="en-US" smtClean="0"/>
-              <a:t>3/4/2026</a:t>
+              <a:t>5/1/2026</a:t>
             </a:fld>
             <a:endParaRPr lang="en-US"/>
           </a:p>
@@ -1923,7 +1923,7 @@
           <a:p>
             <a:fld id="{7EC150B0-FB0A-4485-A89E-5A9600F4FCC2}" type="datetimeFigureOut">
               <a:rPr lang="en-US" smtClean="0"/>
-              <a:t>3/4/2026</a:t>
+              <a:t>5/1/2026</a:t>
             </a:fld>
             <a:endParaRPr lang="en-US"/>
           </a:p>
@@ -2199,7 +2199,7 @@
           <a:p>
             <a:fld id="{7EC150B0-FB0A-4485-A89E-5A9600F4FCC2}" type="datetimeFigureOut">
               <a:rPr lang="en-US" smtClean="0"/>
-              <a:t>3/4/2026</a:t>
+              <a:t>5/1/2026</a:t>
             </a:fld>
             <a:endParaRPr lang="en-US"/>
           </a:p>
@@ -2465,7 +2465,7 @@
           <a:p>
             <a:fld id="{7EC150B0-FB0A-4485-A89E-5A9600F4FCC2}" type="datetimeFigureOut">
               <a:rPr lang="en-US" smtClean="0"/>
-              <a:t>3/4/2026</a:t>
+              <a:t>5/1/2026</a:t>
             </a:fld>
             <a:endParaRPr lang="en-US"/>
           </a:p>
@@ -2878,7 +2878,7 @@
           <a:p>
             <a:fld id="{7EC150B0-FB0A-4485-A89E-5A9600F4FCC2}" type="datetimeFigureOut">
               <a:rPr lang="en-US" smtClean="0"/>
-              <a:t>3/4/2026</a:t>
+              <a:t>5/1/2026</a:t>
             </a:fld>
             <a:endParaRPr lang="en-US"/>
           </a:p>
@@ -3020,7 +3020,7 @@
           <a:p>
             <a:fld id="{7EC150B0-FB0A-4485-A89E-5A9600F4FCC2}" type="datetimeFigureOut">
               <a:rPr lang="en-US" smtClean="0"/>
-              <a:t>3/4/2026</a:t>
+              <a:t>5/1/2026</a:t>
             </a:fld>
             <a:endParaRPr lang="en-US"/>
           </a:p>
@@ -3134,7 +3134,7 @@
           <a:p>
             <a:fld id="{7EC150B0-FB0A-4485-A89E-5A9600F4FCC2}" type="datetimeFigureOut">
               <a:rPr lang="en-US" smtClean="0"/>
-              <a:t>3/4/2026</a:t>
+              <a:t>5/1/2026</a:t>
             </a:fld>
             <a:endParaRPr lang="en-US"/>
           </a:p>
@@ -3446,7 +3446,7 @@
           <a:p>
             <a:fld id="{7EC150B0-FB0A-4485-A89E-5A9600F4FCC2}" type="datetimeFigureOut">
               <a:rPr lang="en-US" smtClean="0"/>
-              <a:t>3/4/2026</a:t>
+              <a:t>5/1/2026</a:t>
             </a:fld>
             <a:endParaRPr lang="en-US"/>
           </a:p>
@@ -3735,7 +3735,7 @@
           <a:p>
             <a:fld id="{7EC150B0-FB0A-4485-A89E-5A9600F4FCC2}" type="datetimeFigureOut">
               <a:rPr lang="en-US" smtClean="0"/>
-              <a:t>3/4/2026</a:t>
+              <a:t>5/1/2026</a:t>
             </a:fld>
             <a:endParaRPr lang="en-US"/>
           </a:p>
@@ -3977,7 +3977,7 @@
           <a:p>
             <a:fld id="{7EC150B0-FB0A-4485-A89E-5A9600F4FCC2}" type="datetimeFigureOut">
               <a:rPr lang="en-US" smtClean="0"/>
-              <a:t>3/4/2026</a:t>
+              <a:t>5/1/2026</a:t>
             </a:fld>
             <a:endParaRPr lang="en-US"/>
           </a:p>
@@ -4639,7 +4639,121 @@
           <p:nvPr/>
         </p:nvPicPr>
         <p:blipFill>
-          <a:blip r:embed="rId3">
+          <a:blip>
+            <a:extLst>
+              <a:ext uri="{96DAC541-7B7A-43D3-8B79-37D633B846F1}">
+                <asvg:svgBlip xmlns:asvg="http://schemas.microsoft.com/office/drawing/2016/SVG/main" r:embed="rId3"/>
+              </a:ext>
+            </a:extLst>
+          </a:blip>
+          <a:stretch>
+            <a:fillRect/>
+          </a:stretch>
+        </p:blipFill>
+        <p:spPr>
+          <a:xfrm>
+            <a:off x="849273" y="2058352"/>
+            <a:ext cx="496133" cy="496133"/>
+          </a:xfrm>
+          <a:prstGeom prst="rect">
+            <a:avLst/>
+          </a:prstGeom>
+        </p:spPr>
+      </p:pic>
+      <p:sp>
+        <p:nvSpPr>
+          <p:cNvPr id="5" name="Text 2"/>
+          <p:cNvSpPr/>
+          <p:nvPr/>
+        </p:nvSpPr>
+        <p:spPr>
+          <a:xfrm>
+            <a:off x="1593413" y="2058352"/>
+            <a:ext cx="2480905" cy="310158"/>
+          </a:xfrm>
+          <a:prstGeom prst="rect">
+            <a:avLst/>
+          </a:prstGeom>
+          <a:noFill/>
+          <a:ln/>
+        </p:spPr>
+        <p:txBody>
+          <a:bodyPr wrap="none" lIns="0" tIns="0" rIns="0" bIns="0" rtlCol="0" anchor="t"/>
+          <a:lstStyle/>
+          <a:p>
+            <a:pPr marL="0" indent="0" algn="l">
+              <a:lnSpc>
+                <a:spcPts val="2400"/>
+              </a:lnSpc>
+              <a:buNone/>
+            </a:pPr>
+            <a:r>
+              <a:rPr lang="en-US" sz="1950" dirty="0">
+                <a:solidFill>
+                  <a:srgbClr val="FFFFFF"/>
+                </a:solidFill>
+                <a:latin typeface="Instrument Sans Semi Bold" pitchFamily="34" charset="0"/>
+                <a:ea typeface="Instrument Sans Semi Bold" pitchFamily="34" charset="-122"/>
+                <a:cs typeface="Instrument Sans Semi Bold" pitchFamily="34" charset="-120"/>
+              </a:rPr>
+              <a:t>Late Detection</a:t>
+            </a:r>
+            <a:endParaRPr lang="en-US" sz="1950" dirty="0"/>
+          </a:p>
+        </p:txBody>
+      </p:sp>
+      <p:sp>
+        <p:nvSpPr>
+          <p:cNvPr id="6" name="Text 3"/>
+          <p:cNvSpPr/>
+          <p:nvPr/>
+        </p:nvSpPr>
+        <p:spPr>
+          <a:xfrm>
+            <a:off x="1593413" y="2566868"/>
+            <a:ext cx="5424249" cy="635079"/>
+          </a:xfrm>
+          <a:prstGeom prst="rect">
+            <a:avLst/>
+          </a:prstGeom>
+          <a:noFill/>
+          <a:ln/>
+        </p:spPr>
+        <p:txBody>
+          <a:bodyPr wrap="square" lIns="0" tIns="0" rIns="0" bIns="0" rtlCol="0" anchor="t"/>
+          <a:lstStyle/>
+          <a:p>
+            <a:pPr marL="0" indent="0" algn="l">
+              <a:lnSpc>
+                <a:spcPts val="2500"/>
+              </a:lnSpc>
+              <a:buNone/>
+            </a:pPr>
+            <a:r>
+              <a:rPr lang="en-US" sz="1550" dirty="0">
+                <a:solidFill>
+                  <a:srgbClr val="FFFFFF"/>
+                </a:solidFill>
+                <a:latin typeface="Instrument Sans Medium" pitchFamily="34" charset="0"/>
+                <a:ea typeface="Instrument Sans Medium" pitchFamily="34" charset="-122"/>
+                <a:cs typeface="Instrument Sans Medium" pitchFamily="34" charset="-120"/>
+              </a:rPr>
+              <a:t>Students are often identified only after failure or a formal dropout request — intervention is then too late.</a:t>
+            </a:r>
+            <a:endParaRPr lang="en-US" sz="1550" dirty="0"/>
+          </a:p>
+        </p:txBody>
+      </p:sp>
+      <p:pic>
+        <p:nvPicPr>
+          <p:cNvPr id="7" name="Image 1" descr="preencoded.png"/>
+          <p:cNvPicPr>
+            <a:picLocks noChangeAspect="1"/>
+          </p:cNvPicPr>
+          <p:nvPr/>
+        </p:nvPicPr>
+        <p:blipFill>
+          <a:blip>
             <a:extLst>
               <a:ext uri="{96DAC541-7B7A-43D3-8B79-37D633B846F1}">
                 <asvg:svgBlip xmlns:asvg="http://schemas.microsoft.com/office/drawing/2016/SVG/main" r:embed="rId4"/>
@@ -4652,120 +4766,6 @@
         </p:blipFill>
         <p:spPr>
           <a:xfrm>
-            <a:off x="849273" y="2058352"/>
-            <a:ext cx="496133" cy="496133"/>
-          </a:xfrm>
-          <a:prstGeom prst="rect">
-            <a:avLst/>
-          </a:prstGeom>
-        </p:spPr>
-      </p:pic>
-      <p:sp>
-        <p:nvSpPr>
-          <p:cNvPr id="5" name="Text 2"/>
-          <p:cNvSpPr/>
-          <p:nvPr/>
-        </p:nvSpPr>
-        <p:spPr>
-          <a:xfrm>
-            <a:off x="1593413" y="2058352"/>
-            <a:ext cx="2480905" cy="310158"/>
-          </a:xfrm>
-          <a:prstGeom prst="rect">
-            <a:avLst/>
-          </a:prstGeom>
-          <a:noFill/>
-          <a:ln/>
-        </p:spPr>
-        <p:txBody>
-          <a:bodyPr wrap="none" lIns="0" tIns="0" rIns="0" bIns="0" rtlCol="0" anchor="t"/>
-          <a:lstStyle/>
-          <a:p>
-            <a:pPr marL="0" indent="0" algn="l">
-              <a:lnSpc>
-                <a:spcPts val="2400"/>
-              </a:lnSpc>
-              <a:buNone/>
-            </a:pPr>
-            <a:r>
-              <a:rPr lang="en-US" sz="1950" dirty="0">
-                <a:solidFill>
-                  <a:srgbClr val="FFFFFF"/>
-                </a:solidFill>
-                <a:latin typeface="Instrument Sans Semi Bold" pitchFamily="34" charset="0"/>
-                <a:ea typeface="Instrument Sans Semi Bold" pitchFamily="34" charset="-122"/>
-                <a:cs typeface="Instrument Sans Semi Bold" pitchFamily="34" charset="-120"/>
-              </a:rPr>
-              <a:t>Late Detection</a:t>
-            </a:r>
-            <a:endParaRPr lang="en-US" sz="1950" dirty="0"/>
-          </a:p>
-        </p:txBody>
-      </p:sp>
-      <p:sp>
-        <p:nvSpPr>
-          <p:cNvPr id="6" name="Text 3"/>
-          <p:cNvSpPr/>
-          <p:nvPr/>
-        </p:nvSpPr>
-        <p:spPr>
-          <a:xfrm>
-            <a:off x="1593413" y="2566868"/>
-            <a:ext cx="5424249" cy="635079"/>
-          </a:xfrm>
-          <a:prstGeom prst="rect">
-            <a:avLst/>
-          </a:prstGeom>
-          <a:noFill/>
-          <a:ln/>
-        </p:spPr>
-        <p:txBody>
-          <a:bodyPr wrap="square" lIns="0" tIns="0" rIns="0" bIns="0" rtlCol="0" anchor="t"/>
-          <a:lstStyle/>
-          <a:p>
-            <a:pPr marL="0" indent="0" algn="l">
-              <a:lnSpc>
-                <a:spcPts val="2500"/>
-              </a:lnSpc>
-              <a:buNone/>
-            </a:pPr>
-            <a:r>
-              <a:rPr lang="en-US" sz="1550" dirty="0">
-                <a:solidFill>
-                  <a:srgbClr val="FFFFFF"/>
-                </a:solidFill>
-                <a:latin typeface="Instrument Sans Medium" pitchFamily="34" charset="0"/>
-                <a:ea typeface="Instrument Sans Medium" pitchFamily="34" charset="-122"/>
-                <a:cs typeface="Instrument Sans Medium" pitchFamily="34" charset="-120"/>
-              </a:rPr>
-              <a:t>Students are often identified only after failure or a formal dropout request — intervention is then too late.</a:t>
-            </a:r>
-            <a:endParaRPr lang="en-US" sz="1550" dirty="0"/>
-          </a:p>
-        </p:txBody>
-      </p:sp>
-      <p:pic>
-        <p:nvPicPr>
-          <p:cNvPr id="7" name="Image 1" descr="preencoded.png"/>
-          <p:cNvPicPr>
-            <a:picLocks noChangeAspect="1"/>
-          </p:cNvPicPr>
-          <p:nvPr/>
-        </p:nvPicPr>
-        <p:blipFill>
-          <a:blip r:embed="rId5">
-            <a:extLst>
-              <a:ext uri="{96DAC541-7B7A-43D3-8B79-37D633B846F1}">
-                <asvg:svgBlip xmlns:asvg="http://schemas.microsoft.com/office/drawing/2016/SVG/main" r:embed="rId6"/>
-              </a:ext>
-            </a:extLst>
-          </a:blip>
-          <a:stretch>
-            <a:fillRect/>
-          </a:stretch>
-        </p:blipFill>
-        <p:spPr>
-          <a:xfrm>
             <a:off x="849273" y="3598783"/>
             <a:ext cx="496133" cy="496133"/>
           </a:xfrm>
@@ -4867,10 +4867,10 @@
           <p:nvPr/>
         </p:nvPicPr>
         <p:blipFill>
-          <a:blip r:embed="rId7">
+          <a:blip>
             <a:extLst>
               <a:ext uri="{96DAC541-7B7A-43D3-8B79-37D633B846F1}">
-                <asvg:svgBlip xmlns:asvg="http://schemas.microsoft.com/office/drawing/2016/SVG/main" r:embed="rId8"/>
+                <asvg:svgBlip xmlns:asvg="http://schemas.microsoft.com/office/drawing/2016/SVG/main" r:embed="rId5"/>
               </a:ext>
             </a:extLst>
           </a:blip>
@@ -4981,10 +4981,10 @@
           <p:nvPr/>
         </p:nvPicPr>
         <p:blipFill>
-          <a:blip r:embed="rId9">
+          <a:blip>
             <a:extLst>
               <a:ext uri="{96DAC541-7B7A-43D3-8B79-37D633B846F1}">
-                <asvg:svgBlip xmlns:asvg="http://schemas.microsoft.com/office/drawing/2016/SVG/main" r:embed="rId10"/>
+                <asvg:svgBlip xmlns:asvg="http://schemas.microsoft.com/office/drawing/2016/SVG/main" r:embed="rId6"/>
               </a:ext>
             </a:extLst>
           </a:blip>
@@ -5807,10 +5807,10 @@
           <p:nvPr/>
         </p:nvPicPr>
         <p:blipFill>
-          <a:blip r:embed="rId3">
+          <a:blip>
             <a:extLst>
               <a:ext uri="{96DAC541-7B7A-43D3-8B79-37D633B846F1}">
-                <asvg:svgBlip xmlns:asvg="http://schemas.microsoft.com/office/drawing/2016/SVG/main" r:embed="rId4"/>
+                <asvg:svgBlip xmlns:asvg="http://schemas.microsoft.com/office/drawing/2016/SVG/main" r:embed="rId3"/>
               </a:ext>
             </a:extLst>
           </a:blip>
@@ -5820,7 +5820,7 @@
         </p:blipFill>
         <p:spPr>
           <a:xfrm>
-            <a:off x="793790" y="3514130"/>
+            <a:off x="5361086" y="3434215"/>
             <a:ext cx="198358" cy="198358"/>
           </a:xfrm>
           <a:prstGeom prst="rect">
@@ -5837,7 +5837,7 @@
           <p:nvPr/>
         </p:nvPicPr>
         <p:blipFill>
-          <a:blip r:embed="rId5"/>
+          <a:blip r:embed="rId4"/>
           <a:stretch>
             <a:fillRect/>
           </a:stretch>
@@ -5860,7 +5860,7 @@
         </p:nvSpPr>
         <p:spPr>
           <a:xfrm>
-            <a:off x="793790" y="3928705"/>
+            <a:off x="5306616" y="3877984"/>
             <a:ext cx="3908107" cy="310158"/>
           </a:xfrm>
           <a:prstGeom prst="rect">
@@ -5902,7 +5902,7 @@
         </p:nvSpPr>
         <p:spPr>
           <a:xfrm>
-            <a:off x="793790" y="4357926"/>
+            <a:off x="5361086" y="4504792"/>
             <a:ext cx="4215289" cy="1270159"/>
           </a:xfrm>
           <a:prstGeom prst="rect">
@@ -5930,7 +5930,51 @@
                 <a:ea typeface="Instrument Sans Medium" pitchFamily="34" charset="-122"/>
                 <a:cs typeface="Instrument Sans Medium" pitchFamily="34" charset="-120"/>
               </a:rPr>
-              <a:t>Build a LangChain + Google Gemini chatbot with conversation memory, periodic wellbeing checks and extraction of behavioural features (sentiment, stress keywords, engagement).</a:t>
+              <a:t>Build a </a:t>
+            </a:r>
+            <a:r>
+              <a:rPr lang="en-US" sz="1550" dirty="0" err="1">
+                <a:solidFill>
+                  <a:srgbClr val="5B5F71"/>
+                </a:solidFill>
+                <a:latin typeface="Instrument Sans Medium" pitchFamily="34" charset="0"/>
+                <a:ea typeface="Instrument Sans Medium" pitchFamily="34" charset="-122"/>
+                <a:cs typeface="Instrument Sans Medium" pitchFamily="34" charset="-120"/>
+              </a:rPr>
+              <a:t>LangChain</a:t>
+            </a:r>
+            <a:r>
+              <a:rPr lang="en-US" sz="1550" dirty="0">
+                <a:solidFill>
+                  <a:srgbClr val="5B5F71"/>
+                </a:solidFill>
+                <a:latin typeface="Instrument Sans Medium" pitchFamily="34" charset="0"/>
+                <a:ea typeface="Instrument Sans Medium" pitchFamily="34" charset="-122"/>
+                <a:cs typeface="Instrument Sans Medium" pitchFamily="34" charset="-120"/>
+              </a:rPr>
+              <a:t> + Google Gemini chatbot with conversation memory, periodic wellbeing checks and extraction of </a:t>
+            </a:r>
+            <a:r>
+              <a:rPr lang="en-US" sz="1550" dirty="0" err="1">
+                <a:solidFill>
+                  <a:srgbClr val="5B5F71"/>
+                </a:solidFill>
+                <a:latin typeface="Instrument Sans Medium" pitchFamily="34" charset="0"/>
+                <a:ea typeface="Instrument Sans Medium" pitchFamily="34" charset="-122"/>
+                <a:cs typeface="Instrument Sans Medium" pitchFamily="34" charset="-120"/>
+              </a:rPr>
+              <a:t>behavioural</a:t>
+            </a:r>
+            <a:r>
+              <a:rPr lang="en-US" sz="1550" dirty="0">
+                <a:solidFill>
+                  <a:srgbClr val="5B5F71"/>
+                </a:solidFill>
+                <a:latin typeface="Instrument Sans Medium" pitchFamily="34" charset="0"/>
+                <a:ea typeface="Instrument Sans Medium" pitchFamily="34" charset="-122"/>
+                <a:cs typeface="Instrument Sans Medium" pitchFamily="34" charset="-120"/>
+              </a:rPr>
+              <a:t> features (sentiment, stress keywords, engagement).</a:t>
             </a:r>
             <a:endParaRPr lang="en-US" sz="1550" dirty="0"/>
           </a:p>
@@ -5945,10 +5989,10 @@
           <p:nvPr/>
         </p:nvPicPr>
         <p:blipFill>
-          <a:blip r:embed="rId6">
+          <a:blip>
             <a:extLst>
               <a:ext uri="{96DAC541-7B7A-43D3-8B79-37D633B846F1}">
-                <asvg:svgBlip xmlns:asvg="http://schemas.microsoft.com/office/drawing/2016/SVG/main" r:embed="rId7"/>
+                <asvg:svgBlip xmlns:asvg="http://schemas.microsoft.com/office/drawing/2016/SVG/main" r:embed="rId5"/>
               </a:ext>
             </a:extLst>
           </a:blip>
@@ -5958,7 +6002,7 @@
         </p:blipFill>
         <p:spPr>
           <a:xfrm>
-            <a:off x="5207437" y="3514130"/>
+            <a:off x="9829204" y="3429743"/>
             <a:ext cx="198358" cy="198358"/>
           </a:xfrm>
           <a:prstGeom prst="rect">
@@ -5975,7 +6019,7 @@
           <p:nvPr/>
         </p:nvPicPr>
         <p:blipFill>
-          <a:blip r:embed="rId5"/>
+          <a:blip r:embed="rId4"/>
           <a:stretch>
             <a:fillRect/>
           </a:stretch>
@@ -5998,7 +6042,7 @@
         </p:nvSpPr>
         <p:spPr>
           <a:xfrm>
-            <a:off x="5207437" y="3928705"/>
+            <a:off x="9779450" y="3877984"/>
             <a:ext cx="3769281" cy="310158"/>
           </a:xfrm>
           <a:prstGeom prst="rect">
@@ -6040,7 +6084,7 @@
         </p:nvSpPr>
         <p:spPr>
           <a:xfrm>
-            <a:off x="5207437" y="4357926"/>
+            <a:off x="9779450" y="4504791"/>
             <a:ext cx="4215408" cy="1270159"/>
           </a:xfrm>
           <a:prstGeom prst="rect">
@@ -6083,10 +6127,10 @@
           <p:nvPr/>
         </p:nvPicPr>
         <p:blipFill>
-          <a:blip r:embed="rId8">
+          <a:blip>
             <a:extLst>
               <a:ext uri="{96DAC541-7B7A-43D3-8B79-37D633B846F1}">
-                <asvg:svgBlip xmlns:asvg="http://schemas.microsoft.com/office/drawing/2016/SVG/main" r:embed="rId9"/>
+                <asvg:svgBlip xmlns:asvg="http://schemas.microsoft.com/office/drawing/2016/SVG/main" r:embed="rId6"/>
               </a:ext>
             </a:extLst>
           </a:blip>
@@ -6096,7 +6140,7 @@
         </p:blipFill>
         <p:spPr>
           <a:xfrm>
-            <a:off x="9621203" y="3514130"/>
+            <a:off x="793789" y="3535072"/>
             <a:ext cx="198358" cy="198358"/>
           </a:xfrm>
           <a:prstGeom prst="rect">
@@ -6113,7 +6157,7 @@
           <p:nvPr/>
         </p:nvPicPr>
         <p:blipFill>
-          <a:blip r:embed="rId5"/>
+          <a:blip r:embed="rId4"/>
           <a:stretch>
             <a:fillRect/>
           </a:stretch>
@@ -6136,7 +6180,7 @@
         </p:nvSpPr>
         <p:spPr>
           <a:xfrm>
-            <a:off x="9621203" y="3928705"/>
+            <a:off x="793789" y="3959721"/>
             <a:ext cx="2797612" cy="310158"/>
           </a:xfrm>
           <a:prstGeom prst="rect">
@@ -6178,7 +6222,7 @@
         </p:nvSpPr>
         <p:spPr>
           <a:xfrm>
-            <a:off x="9621203" y="4357926"/>
+            <a:off x="793790" y="4504793"/>
             <a:ext cx="4215289" cy="1270159"/>
           </a:xfrm>
           <a:prstGeom prst="rect">
@@ -6501,7 +6545,121 @@
           <p:nvPr/>
         </p:nvPicPr>
         <p:blipFill>
-          <a:blip r:embed="rId3">
+          <a:blip>
+            <a:extLst>
+              <a:ext uri="{96DAC541-7B7A-43D3-8B79-37D633B846F1}">
+                <asvg:svgBlip xmlns:asvg="http://schemas.microsoft.com/office/drawing/2016/SVG/main" r:embed="rId3"/>
+              </a:ext>
+            </a:extLst>
+          </a:blip>
+          <a:stretch>
+            <a:fillRect/>
+          </a:stretch>
+        </p:blipFill>
+        <p:spPr>
+          <a:xfrm>
+            <a:off x="732711" y="1657588"/>
+            <a:ext cx="457914" cy="457914"/>
+          </a:xfrm>
+          <a:prstGeom prst="rect">
+            <a:avLst/>
+          </a:prstGeom>
+        </p:spPr>
+      </p:pic>
+      <p:sp>
+        <p:nvSpPr>
+          <p:cNvPr id="4" name="Text 1"/>
+          <p:cNvSpPr/>
+          <p:nvPr/>
+        </p:nvSpPr>
+        <p:spPr>
+          <a:xfrm>
+            <a:off x="732711" y="2326838"/>
+            <a:ext cx="2290048" cy="286107"/>
+          </a:xfrm>
+          <a:prstGeom prst="rect">
+            <a:avLst/>
+          </a:prstGeom>
+          <a:noFill/>
+          <a:ln/>
+        </p:spPr>
+        <p:txBody>
+          <a:bodyPr wrap="none" lIns="0" tIns="0" rIns="0" bIns="0" rtlCol="0" anchor="t"/>
+          <a:lstStyle/>
+          <a:p>
+            <a:pPr marL="0" indent="0" algn="l">
+              <a:lnSpc>
+                <a:spcPts val="2250"/>
+              </a:lnSpc>
+              <a:buNone/>
+            </a:pPr>
+            <a:r>
+              <a:rPr lang="en-US" sz="1800" dirty="0">
+                <a:solidFill>
+                  <a:srgbClr val="5B5F71"/>
+                </a:solidFill>
+                <a:latin typeface="Instrument Sans Semi Bold" pitchFamily="34" charset="0"/>
+                <a:ea typeface="Instrument Sans Semi Bold" pitchFamily="34" charset="-122"/>
+                <a:cs typeface="Instrument Sans Semi Bold" pitchFamily="34" charset="-120"/>
+              </a:rPr>
+              <a:t>Backend</a:t>
+            </a:r>
+            <a:endParaRPr lang="en-US" sz="1800" dirty="0"/>
+          </a:p>
+        </p:txBody>
+      </p:sp>
+      <p:sp>
+        <p:nvSpPr>
+          <p:cNvPr id="5" name="Text 2"/>
+          <p:cNvSpPr/>
+          <p:nvPr/>
+        </p:nvSpPr>
+        <p:spPr>
+          <a:xfrm>
+            <a:off x="732711" y="2782014"/>
+            <a:ext cx="6359009" cy="563642"/>
+          </a:xfrm>
+          <a:prstGeom prst="rect">
+            <a:avLst/>
+          </a:prstGeom>
+          <a:noFill/>
+          <a:ln/>
+        </p:spPr>
+        <p:txBody>
+          <a:bodyPr wrap="square" lIns="0" tIns="0" rIns="0" bIns="0" rtlCol="0" anchor="t"/>
+          <a:lstStyle/>
+          <a:p>
+            <a:pPr marL="0" indent="0" algn="l">
+              <a:lnSpc>
+                <a:spcPts val="2200"/>
+              </a:lnSpc>
+              <a:buNone/>
+            </a:pPr>
+            <a:r>
+              <a:rPr lang="en-US" sz="1400" dirty="0">
+                <a:solidFill>
+                  <a:srgbClr val="5B5F71"/>
+                </a:solidFill>
+                <a:latin typeface="Instrument Sans Medium" pitchFamily="34" charset="0"/>
+                <a:ea typeface="Instrument Sans Medium" pitchFamily="34" charset="-122"/>
+                <a:cs typeface="Instrument Sans Medium" pitchFamily="34" charset="-120"/>
+              </a:rPr>
+              <a:t>Python 3.10+, Flask, Flask‑SocketIO; REST APIs and webhook handlers for Twilio.</a:t>
+            </a:r>
+            <a:endParaRPr lang="en-US" sz="1400" dirty="0"/>
+          </a:p>
+        </p:txBody>
+      </p:sp>
+      <p:pic>
+        <p:nvPicPr>
+          <p:cNvPr id="6" name="Image 1" descr="preencoded.png"/>
+          <p:cNvPicPr>
+            <a:picLocks noChangeAspect="1"/>
+          </p:cNvPicPr>
+          <p:nvPr/>
+        </p:nvPicPr>
+        <p:blipFill>
+          <a:blip>
             <a:extLst>
               <a:ext uri="{96DAC541-7B7A-43D3-8B79-37D633B846F1}">
                 <asvg:svgBlip xmlns:asvg="http://schemas.microsoft.com/office/drawing/2016/SVG/main" r:embed="rId4"/>
@@ -6514,7 +6672,7 @@
         </p:blipFill>
         <p:spPr>
           <a:xfrm>
-            <a:off x="732711" y="1657588"/>
+            <a:off x="732711" y="3683794"/>
             <a:ext cx="457914" cy="457914"/>
           </a:xfrm>
           <a:prstGeom prst="rect">
@@ -6524,13 +6682,13 @@
       </p:pic>
       <p:sp>
         <p:nvSpPr>
-          <p:cNvPr id="4" name="Text 1"/>
+          <p:cNvPr id="7" name="Text 3"/>
           <p:cNvSpPr/>
           <p:nvPr/>
         </p:nvSpPr>
         <p:spPr>
           <a:xfrm>
-            <a:off x="732711" y="2326838"/>
+            <a:off x="732711" y="4353044"/>
             <a:ext cx="2290048" cy="286107"/>
           </a:xfrm>
           <a:prstGeom prst="rect">
@@ -6558,7 +6716,7 @@
                 <a:ea typeface="Instrument Sans Semi Bold" pitchFamily="34" charset="-122"/>
                 <a:cs typeface="Instrument Sans Semi Bold" pitchFamily="34" charset="-120"/>
               </a:rPr>
-              <a:t>Backend</a:t>
+              <a:t>AI &amp; NLP</a:t>
             </a:r>
             <a:endParaRPr lang="en-US" sz="1800" dirty="0"/>
           </a:p>
@@ -6566,13 +6724,13 @@
       </p:sp>
       <p:sp>
         <p:nvSpPr>
-          <p:cNvPr id="5" name="Text 2"/>
+          <p:cNvPr id="8" name="Text 4"/>
           <p:cNvSpPr/>
           <p:nvPr/>
         </p:nvSpPr>
         <p:spPr>
           <a:xfrm>
-            <a:off x="732711" y="2782014"/>
+            <a:off x="732711" y="4808220"/>
             <a:ext cx="6359009" cy="563642"/>
           </a:xfrm>
           <a:prstGeom prst="rect">
@@ -6600,7 +6758,7 @@
                 <a:ea typeface="Instrument Sans Medium" pitchFamily="34" charset="-122"/>
                 <a:cs typeface="Instrument Sans Medium" pitchFamily="34" charset="-120"/>
               </a:rPr>
-              <a:t>Python 3.10+, Flask, Flask‑SocketIO; REST APIs and webhook handlers for Twilio.</a:t>
+              <a:t>LangChain orchestration, Google Gemini for LLM responses, VADER for sentiment, NLTK for preprocessing.</a:t>
             </a:r>
             <a:endParaRPr lang="en-US" sz="1400" dirty="0"/>
           </a:p>
@@ -6608,14 +6766,128 @@
       </p:sp>
       <p:pic>
         <p:nvPicPr>
-          <p:cNvPr id="6" name="Image 1" descr="preencoded.png"/>
+          <p:cNvPr id="9" name="Image 2" descr="preencoded.png"/>
           <p:cNvPicPr>
             <a:picLocks noChangeAspect="1"/>
           </p:cNvPicPr>
           <p:nvPr/>
         </p:nvPicPr>
         <p:blipFill>
-          <a:blip r:embed="rId5">
+          <a:blip>
+            <a:extLst>
+              <a:ext uri="{96DAC541-7B7A-43D3-8B79-37D633B846F1}">
+                <asvg:svgBlip xmlns:asvg="http://schemas.microsoft.com/office/drawing/2016/SVG/main" r:embed="rId5"/>
+              </a:ext>
+            </a:extLst>
+          </a:blip>
+          <a:stretch>
+            <a:fillRect/>
+          </a:stretch>
+        </p:blipFill>
+        <p:spPr>
+          <a:xfrm>
+            <a:off x="732711" y="5709999"/>
+            <a:ext cx="457914" cy="457914"/>
+          </a:xfrm>
+          <a:prstGeom prst="rect">
+            <a:avLst/>
+          </a:prstGeom>
+        </p:spPr>
+      </p:pic>
+      <p:sp>
+        <p:nvSpPr>
+          <p:cNvPr id="10" name="Text 5"/>
+          <p:cNvSpPr/>
+          <p:nvPr/>
+        </p:nvSpPr>
+        <p:spPr>
+          <a:xfrm>
+            <a:off x="732711" y="6379250"/>
+            <a:ext cx="2290048" cy="286107"/>
+          </a:xfrm>
+          <a:prstGeom prst="rect">
+            <a:avLst/>
+          </a:prstGeom>
+          <a:noFill/>
+          <a:ln/>
+        </p:spPr>
+        <p:txBody>
+          <a:bodyPr wrap="none" lIns="0" tIns="0" rIns="0" bIns="0" rtlCol="0" anchor="t"/>
+          <a:lstStyle/>
+          <a:p>
+            <a:pPr marL="0" indent="0" algn="l">
+              <a:lnSpc>
+                <a:spcPts val="2250"/>
+              </a:lnSpc>
+              <a:buNone/>
+            </a:pPr>
+            <a:r>
+              <a:rPr lang="en-US" sz="1800" dirty="0">
+                <a:solidFill>
+                  <a:srgbClr val="5B5F71"/>
+                </a:solidFill>
+                <a:latin typeface="Instrument Sans Semi Bold" pitchFamily="34" charset="0"/>
+                <a:ea typeface="Instrument Sans Semi Bold" pitchFamily="34" charset="-122"/>
+                <a:cs typeface="Instrument Sans Semi Bold" pitchFamily="34" charset="-120"/>
+              </a:rPr>
+              <a:t>Machine Learning</a:t>
+            </a:r>
+            <a:endParaRPr lang="en-US" sz="1800" dirty="0"/>
+          </a:p>
+        </p:txBody>
+      </p:sp>
+      <p:sp>
+        <p:nvSpPr>
+          <p:cNvPr id="11" name="Text 6"/>
+          <p:cNvSpPr/>
+          <p:nvPr/>
+        </p:nvSpPr>
+        <p:spPr>
+          <a:xfrm>
+            <a:off x="732711" y="6834426"/>
+            <a:ext cx="6359009" cy="563642"/>
+          </a:xfrm>
+          <a:prstGeom prst="rect">
+            <a:avLst/>
+          </a:prstGeom>
+          <a:noFill/>
+          <a:ln/>
+        </p:spPr>
+        <p:txBody>
+          <a:bodyPr wrap="square" lIns="0" tIns="0" rIns="0" bIns="0" rtlCol="0" anchor="t"/>
+          <a:lstStyle/>
+          <a:p>
+            <a:pPr marL="0" indent="0" algn="l">
+              <a:lnSpc>
+                <a:spcPts val="2200"/>
+              </a:lnSpc>
+              <a:buNone/>
+            </a:pPr>
+            <a:r>
+              <a:rPr lang="en-US" sz="1400" dirty="0">
+                <a:solidFill>
+                  <a:srgbClr val="5B5F71"/>
+                </a:solidFill>
+                <a:latin typeface="Instrument Sans Medium" pitchFamily="34" charset="0"/>
+                <a:ea typeface="Instrument Sans Medium" pitchFamily="34" charset="-122"/>
+                <a:cs typeface="Instrument Sans Medium" pitchFamily="34" charset="-120"/>
+              </a:rPr>
+              <a:t>Scikit‑learn Random Forest, Pandas, NumPy for feature engineering and evaluation.</a:t>
+            </a:r>
+            <a:endParaRPr lang="en-US" sz="1400" dirty="0"/>
+          </a:p>
+        </p:txBody>
+      </p:sp>
+      <p:pic>
+        <p:nvPicPr>
+          <p:cNvPr id="12" name="Image 3" descr="preencoded.png"/>
+          <p:cNvPicPr>
+            <a:picLocks noChangeAspect="1"/>
+          </p:cNvPicPr>
+          <p:nvPr/>
+        </p:nvPicPr>
+        <p:blipFill>
+          <a:blip>
             <a:extLst>
               <a:ext uri="{96DAC541-7B7A-43D3-8B79-37D633B846F1}">
                 <asvg:svgBlip xmlns:asvg="http://schemas.microsoft.com/office/drawing/2016/SVG/main" r:embed="rId6"/>
@@ -6628,234 +6900,6 @@
         </p:blipFill>
         <p:spPr>
           <a:xfrm>
-            <a:off x="732711" y="3683794"/>
-            <a:ext cx="457914" cy="457914"/>
-          </a:xfrm>
-          <a:prstGeom prst="rect">
-            <a:avLst/>
-          </a:prstGeom>
-        </p:spPr>
-      </p:pic>
-      <p:sp>
-        <p:nvSpPr>
-          <p:cNvPr id="7" name="Text 3"/>
-          <p:cNvSpPr/>
-          <p:nvPr/>
-        </p:nvSpPr>
-        <p:spPr>
-          <a:xfrm>
-            <a:off x="732711" y="4353044"/>
-            <a:ext cx="2290048" cy="286107"/>
-          </a:xfrm>
-          <a:prstGeom prst="rect">
-            <a:avLst/>
-          </a:prstGeom>
-          <a:noFill/>
-          <a:ln/>
-        </p:spPr>
-        <p:txBody>
-          <a:bodyPr wrap="none" lIns="0" tIns="0" rIns="0" bIns="0" rtlCol="0" anchor="t"/>
-          <a:lstStyle/>
-          <a:p>
-            <a:pPr marL="0" indent="0" algn="l">
-              <a:lnSpc>
-                <a:spcPts val="2250"/>
-              </a:lnSpc>
-              <a:buNone/>
-            </a:pPr>
-            <a:r>
-              <a:rPr lang="en-US" sz="1800" dirty="0">
-                <a:solidFill>
-                  <a:srgbClr val="5B5F71"/>
-                </a:solidFill>
-                <a:latin typeface="Instrument Sans Semi Bold" pitchFamily="34" charset="0"/>
-                <a:ea typeface="Instrument Sans Semi Bold" pitchFamily="34" charset="-122"/>
-                <a:cs typeface="Instrument Sans Semi Bold" pitchFamily="34" charset="-120"/>
-              </a:rPr>
-              <a:t>AI &amp; NLP</a:t>
-            </a:r>
-            <a:endParaRPr lang="en-US" sz="1800" dirty="0"/>
-          </a:p>
-        </p:txBody>
-      </p:sp>
-      <p:sp>
-        <p:nvSpPr>
-          <p:cNvPr id="8" name="Text 4"/>
-          <p:cNvSpPr/>
-          <p:nvPr/>
-        </p:nvSpPr>
-        <p:spPr>
-          <a:xfrm>
-            <a:off x="732711" y="4808220"/>
-            <a:ext cx="6359009" cy="563642"/>
-          </a:xfrm>
-          <a:prstGeom prst="rect">
-            <a:avLst/>
-          </a:prstGeom>
-          <a:noFill/>
-          <a:ln/>
-        </p:spPr>
-        <p:txBody>
-          <a:bodyPr wrap="square" lIns="0" tIns="0" rIns="0" bIns="0" rtlCol="0" anchor="t"/>
-          <a:lstStyle/>
-          <a:p>
-            <a:pPr marL="0" indent="0" algn="l">
-              <a:lnSpc>
-                <a:spcPts val="2200"/>
-              </a:lnSpc>
-              <a:buNone/>
-            </a:pPr>
-            <a:r>
-              <a:rPr lang="en-US" sz="1400" dirty="0">
-                <a:solidFill>
-                  <a:srgbClr val="5B5F71"/>
-                </a:solidFill>
-                <a:latin typeface="Instrument Sans Medium" pitchFamily="34" charset="0"/>
-                <a:ea typeface="Instrument Sans Medium" pitchFamily="34" charset="-122"/>
-                <a:cs typeface="Instrument Sans Medium" pitchFamily="34" charset="-120"/>
-              </a:rPr>
-              <a:t>LangChain orchestration, Google Gemini for LLM responses, VADER for sentiment, NLTK for preprocessing.</a:t>
-            </a:r>
-            <a:endParaRPr lang="en-US" sz="1400" dirty="0"/>
-          </a:p>
-        </p:txBody>
-      </p:sp>
-      <p:pic>
-        <p:nvPicPr>
-          <p:cNvPr id="9" name="Image 2" descr="preencoded.png"/>
-          <p:cNvPicPr>
-            <a:picLocks noChangeAspect="1"/>
-          </p:cNvPicPr>
-          <p:nvPr/>
-        </p:nvPicPr>
-        <p:blipFill>
-          <a:blip r:embed="rId7">
-            <a:extLst>
-              <a:ext uri="{96DAC541-7B7A-43D3-8B79-37D633B846F1}">
-                <asvg:svgBlip xmlns:asvg="http://schemas.microsoft.com/office/drawing/2016/SVG/main" r:embed="rId8"/>
-              </a:ext>
-            </a:extLst>
-          </a:blip>
-          <a:stretch>
-            <a:fillRect/>
-          </a:stretch>
-        </p:blipFill>
-        <p:spPr>
-          <a:xfrm>
-            <a:off x="732711" y="5709999"/>
-            <a:ext cx="457914" cy="457914"/>
-          </a:xfrm>
-          <a:prstGeom prst="rect">
-            <a:avLst/>
-          </a:prstGeom>
-        </p:spPr>
-      </p:pic>
-      <p:sp>
-        <p:nvSpPr>
-          <p:cNvPr id="10" name="Text 5"/>
-          <p:cNvSpPr/>
-          <p:nvPr/>
-        </p:nvSpPr>
-        <p:spPr>
-          <a:xfrm>
-            <a:off x="732711" y="6379250"/>
-            <a:ext cx="2290048" cy="286107"/>
-          </a:xfrm>
-          <a:prstGeom prst="rect">
-            <a:avLst/>
-          </a:prstGeom>
-          <a:noFill/>
-          <a:ln/>
-        </p:spPr>
-        <p:txBody>
-          <a:bodyPr wrap="none" lIns="0" tIns="0" rIns="0" bIns="0" rtlCol="0" anchor="t"/>
-          <a:lstStyle/>
-          <a:p>
-            <a:pPr marL="0" indent="0" algn="l">
-              <a:lnSpc>
-                <a:spcPts val="2250"/>
-              </a:lnSpc>
-              <a:buNone/>
-            </a:pPr>
-            <a:r>
-              <a:rPr lang="en-US" sz="1800" dirty="0">
-                <a:solidFill>
-                  <a:srgbClr val="5B5F71"/>
-                </a:solidFill>
-                <a:latin typeface="Instrument Sans Semi Bold" pitchFamily="34" charset="0"/>
-                <a:ea typeface="Instrument Sans Semi Bold" pitchFamily="34" charset="-122"/>
-                <a:cs typeface="Instrument Sans Semi Bold" pitchFamily="34" charset="-120"/>
-              </a:rPr>
-              <a:t>Machine Learning</a:t>
-            </a:r>
-            <a:endParaRPr lang="en-US" sz="1800" dirty="0"/>
-          </a:p>
-        </p:txBody>
-      </p:sp>
-      <p:sp>
-        <p:nvSpPr>
-          <p:cNvPr id="11" name="Text 6"/>
-          <p:cNvSpPr/>
-          <p:nvPr/>
-        </p:nvSpPr>
-        <p:spPr>
-          <a:xfrm>
-            <a:off x="732711" y="6834426"/>
-            <a:ext cx="6359009" cy="563642"/>
-          </a:xfrm>
-          <a:prstGeom prst="rect">
-            <a:avLst/>
-          </a:prstGeom>
-          <a:noFill/>
-          <a:ln/>
-        </p:spPr>
-        <p:txBody>
-          <a:bodyPr wrap="square" lIns="0" tIns="0" rIns="0" bIns="0" rtlCol="0" anchor="t"/>
-          <a:lstStyle/>
-          <a:p>
-            <a:pPr marL="0" indent="0" algn="l">
-              <a:lnSpc>
-                <a:spcPts val="2200"/>
-              </a:lnSpc>
-              <a:buNone/>
-            </a:pPr>
-            <a:r>
-              <a:rPr lang="en-US" sz="1400" dirty="0">
-                <a:solidFill>
-                  <a:srgbClr val="5B5F71"/>
-                </a:solidFill>
-                <a:latin typeface="Instrument Sans Medium" pitchFamily="34" charset="0"/>
-                <a:ea typeface="Instrument Sans Medium" pitchFamily="34" charset="-122"/>
-                <a:cs typeface="Instrument Sans Medium" pitchFamily="34" charset="-120"/>
-              </a:rPr>
-              <a:t>Scikit‑learn Random Forest, Pandas, NumPy for feature engineering and evaluation.</a:t>
-            </a:r>
-            <a:endParaRPr lang="en-US" sz="1400" dirty="0"/>
-          </a:p>
-        </p:txBody>
-      </p:sp>
-      <p:pic>
-        <p:nvPicPr>
-          <p:cNvPr id="12" name="Image 3" descr="preencoded.png"/>
-          <p:cNvPicPr>
-            <a:picLocks noChangeAspect="1"/>
-          </p:cNvPicPr>
-          <p:nvPr/>
-        </p:nvPicPr>
-        <p:blipFill>
-          <a:blip r:embed="rId9">
-            <a:extLst>
-              <a:ext uri="{96DAC541-7B7A-43D3-8B79-37D633B846F1}">
-                <asvg:svgBlip xmlns:asvg="http://schemas.microsoft.com/office/drawing/2016/SVG/main" r:embed="rId10"/>
-              </a:ext>
-            </a:extLst>
-          </a:blip>
-          <a:stretch>
-            <a:fillRect/>
-          </a:stretch>
-        </p:blipFill>
-        <p:spPr>
-          <a:xfrm>
             <a:off x="7546300" y="1657588"/>
             <a:ext cx="457914" cy="457914"/>
           </a:xfrm>
@@ -6957,10 +7001,10 @@
           <p:nvPr/>
         </p:nvPicPr>
         <p:blipFill>
-          <a:blip r:embed="rId11">
+          <a:blip>
             <a:extLst>
               <a:ext uri="{96DAC541-7B7A-43D3-8B79-37D633B846F1}">
-                <asvg:svgBlip xmlns:asvg="http://schemas.microsoft.com/office/drawing/2016/SVG/main" r:embed="rId12"/>
+                <asvg:svgBlip xmlns:asvg="http://schemas.microsoft.com/office/drawing/2016/SVG/main" r:embed="rId7"/>
               </a:ext>
             </a:extLst>
           </a:blip>
@@ -7071,10 +7115,10 @@
           <p:nvPr/>
         </p:nvPicPr>
         <p:blipFill>
-          <a:blip r:embed="rId13">
+          <a:blip>
             <a:extLst>
               <a:ext uri="{96DAC541-7B7A-43D3-8B79-37D633B846F1}">
-                <asvg:svgBlip xmlns:asvg="http://schemas.microsoft.com/office/drawing/2016/SVG/main" r:embed="rId14"/>
+                <asvg:svgBlip xmlns:asvg="http://schemas.microsoft.com/office/drawing/2016/SVG/main" r:embed="rId8"/>
               </a:ext>
             </a:extLst>
           </a:blip>

</xml_diff>